<commit_message>
Restore the deleted beat 6 slide to the W6 deck
"A learned model made it worse." was deleted from the .pptx during
PowerPoint editing. Reinserted at position 6 with the re-sorted
w6_human_ladder.png and its SAY/EVIDENCE/WATCH notes, sized to match the
neighbouring human-branch slide rather than to the script's fit-to-frame
default, on the deck's FCFCFB background.

Verified byte-identical on all nineteen pre-existing slides: geometry,
text, image content, notes and background.

src/build_deck.py is still stale -- the headline edits, background color
and per-figure resizes have not been ported back.

Co-Authored-By: Claude Opus 5 <noreply@anthropic.com>
</commit_message>
<xml_diff>
--- a/coursework/W6/MSDS696_W6_Deck.pptx
+++ b/coursework/W6/MSDS696_W6_Deck.pptx
@@ -14,6 +14,7 @@
     <p:sldId id="259" r:id="rId5"/>
     <p:sldId id="260" r:id="rId6"/>
     <p:sldId id="261" r:id="rId7"/>
+    <p:sldId id="276" r:id="rId26"/>
     <p:sldId id="263" r:id="rId8"/>
     <p:sldId id="264" r:id="rId9"/>
     <p:sldId id="265" r:id="rId10"/>
@@ -1556,6 +1557,115 @@
           </p:nvPr>
         </p:nvSpPr>
         <p:spPr/>
+      </p:sp>
+    </p:spTree>
+  </p:cSld>
+  <p:clrMapOvr>
+    <a:masterClrMapping/>
+  </p:clrMapOvr>
+</p:notes>
+</file>
+
+<file path=ppt/notesSlides/notesSlide20.xml><?xml version="1.0" encoding="utf-8"?>
+<p:notes xmlns:a="http://schemas.openxmlformats.org/drawingml/2006/main" xmlns:p="http://schemas.openxmlformats.org/presentationml/2006/main" xmlns:r="http://schemas.openxmlformats.org/officeDocument/2006/relationships">
+  <p:cSld>
+    <p:spTree>
+      <p:nvGrpSpPr>
+        <p:cNvPr id="1" name=""/>
+        <p:cNvGrpSpPr/>
+        <p:nvPr/>
+      </p:nvGrpSpPr>
+      <p:grpSpPr>
+        <a:xfrm>
+          <a:off x="0" y="0"/>
+          <a:ext cx="0" cy="0"/>
+          <a:chOff x="0" y="0"/>
+          <a:chExt cx="0" cy="0"/>
+        </a:xfrm>
+      </p:grpSpPr>
+      <p:sp>
+        <p:nvSpPr>
+          <p:cNvPr id="2" name="Slide Image Placeholder 1"/>
+          <p:cNvSpPr>
+            <a:spLocks noGrp="1" noRot="1" noChangeAspect="1"/>
+          </p:cNvSpPr>
+          <p:nvPr>
+            <p:ph type="sldImg" idx="2"/>
+          </p:nvPr>
+        </p:nvSpPr>
+        <p:spPr/>
+        <p:txBody>
+          <a:bodyPr/>
+          <a:p/>
+        </p:txBody>
+      </p:sp>
+      <p:sp>
+        <p:nvSpPr>
+          <p:cNvPr id="3" name="Notes Placeholder 2"/>
+          <p:cNvSpPr>
+            <a:spLocks noGrp="1"/>
+          </p:cNvSpPr>
+          <p:nvPr>
+            <p:ph type="body" sz="quarter" idx="3"/>
+          </p:nvPr>
+        </p:nvSpPr>
+        <p:spPr/>
+        <p:txBody>
+          <a:bodyPr/>
+          <a:lstStyle/>
+          <a:p>
+            <a:r>
+              <a:t>EVIDENCE —</a:t>
+            </a:r>
+          </a:p>
+          <a:p>
+            <a:r>
+              <a:t>- Three rungs against the floor line: the region's own history names the leading human cause 54% of the time; gradient boosting on region character 36%; the same model given that history as a feature 47%.</a:t>
+            </a:r>
+          </a:p>
+          <a:p>
+            <a:r>
+              <a:t>- Acre-weighted TVD 0.489 / 0.588 / 0.554.</a:t>
+            </a:r>
+          </a:p>
+          <a:p>
+            <a:r>
+              <a:t>- Even handed the winning quantity, the model cannot beat taking its mean.</a:t>
+            </a:r>
+          </a:p>
+          <a:p/>
+          <a:p>
+            <a:r>
+              <a:t>WATCH —</a:t>
+            </a:r>
+          </a:p>
+          <a:p>
+            <a:r>
+              <a:t>- Concede the fair part: the rungs were run once at standard settings and not tuned. What the result rules out is "you never gave it the right features."</a:t>
+            </a:r>
+          </a:p>
+          <a:p>
+            <a:r>
+              <a:t>- Keep this beat — it is the only one conceding a model was tried and lost, which is what keeps the nulls credible.</a:t>
+            </a:r>
+          </a:p>
+        </p:txBody>
+      </p:sp>
+      <p:sp>
+        <p:nvSpPr>
+          <p:cNvPr id="4" name="Slide Number Placeholder 3"/>
+          <p:cNvSpPr>
+            <a:spLocks noGrp="1"/>
+          </p:cNvSpPr>
+          <p:nvPr>
+            <p:ph type="sldNum" sz="quarter" idx="5"/>
+          </p:nvPr>
+        </p:nvSpPr>
+        <p:spPr/>
+        <p:txBody>
+          <a:bodyPr/>
+          <a:p/>
+        </p:txBody>
       </p:sp>
     </p:spTree>
   </p:cSld>
@@ -6474,6 +6584,91 @@
           </a:p>
         </p:txBody>
       </p:sp>
+    </p:spTree>
+  </p:cSld>
+  <p:clrMapOvr>
+    <a:masterClrMapping/>
+  </p:clrMapOvr>
+</p:sld>
+</file>
+
+<file path=ppt/slides/slide20.xml><?xml version="1.0" encoding="utf-8"?>
+<p:sld xmlns:a="http://schemas.openxmlformats.org/drawingml/2006/main" xmlns:p="http://schemas.openxmlformats.org/presentationml/2006/main" xmlns:r="http://schemas.openxmlformats.org/officeDocument/2006/relationships">
+  <p:cSld>
+    <p:bg>
+      <p:bgPr>
+        <a:solidFill>
+          <a:srgbClr val="FCFCFB"/>
+        </a:solidFill>
+        <a:effectLst/>
+      </p:bgPr>
+    </p:bg>
+    <p:spTree>
+      <p:nvGrpSpPr>
+        <p:cNvPr id="1" name=""/>
+        <p:cNvGrpSpPr/>
+        <p:nvPr/>
+      </p:nvGrpSpPr>
+      <p:grpSpPr/>
+      <p:sp>
+        <p:nvSpPr>
+          <p:cNvPr id="2" name="TextBox 1"/>
+          <p:cNvSpPr txBox="1"/>
+          <p:nvPr/>
+        </p:nvSpPr>
+        <p:spPr>
+          <a:xfrm>
+            <a:off x="548640" y="411480"/>
+            <a:ext cx="11094415" cy="1234440"/>
+          </a:xfrm>
+          <a:prstGeom prst="rect">
+            <a:avLst/>
+          </a:prstGeom>
+          <a:noFill/>
+        </p:spPr>
+        <p:txBody>
+          <a:bodyPr wrap="square" anchor="t">
+            <a:spAutoFit/>
+          </a:bodyPr>
+          <a:lstStyle/>
+          <a:p>
+            <a:pPr algn="l"/>
+            <a:r>
+              <a:rPr sz="3000" b="1">
+                <a:solidFill>
+                  <a:srgbClr val="1A1A1A"/>
+                </a:solidFill>
+                <a:latin typeface="Helvetica Neue"/>
+              </a:rPr>
+              <a:t>A learned model made it worse.</a:t>
+            </a:r>
+          </a:p>
+        </p:txBody>
+      </p:sp>
+      <p:pic>
+        <p:nvPicPr>
+          <p:cNvPr id="3" name="Picture 2" descr="w6_human_ladder.png"/>
+          <p:cNvPicPr>
+            <a:picLocks noChangeAspect="1"/>
+          </p:cNvPicPr>
+          <p:nvPr/>
+        </p:nvPicPr>
+        <p:blipFill>
+          <a:blip r:embed="rId2"/>
+          <a:stretch>
+            <a:fillRect/>
+          </a:stretch>
+        </p:blipFill>
+        <p:spPr>
+          <a:xfrm>
+            <a:off x="548640" y="1857146"/>
+            <a:ext cx="11094415" cy="3887621"/>
+          </a:xfrm>
+          <a:prstGeom prst="rect">
+            <a:avLst/>
+          </a:prstGeom>
+        </p:spPr>
+      </p:pic>
     </p:spTree>
   </p:cSld>
   <p:clrMapOvr>

</xml_diff>